<commit_message>
Deploying to gh-pages from @ w4bo/slides-markdown@190edb1710e975e58b2fdfab5576d200cb8d521a 🚀
</commit_message>
<xml_diff>
--- a/prova.pptx
+++ b/prova.pptx
@@ -3716,7 +3716,7 @@
             </a:pPr>
             <a:r>
               <a:rPr/>
-              <a:t>Left column (Francia, Gallinucci, and Golfarelli 2024)</a:t>
+              <a:t>Left column (Francia et al. 2024)</a:t>
             </a:r>
           </a:p>
           <a:p>
@@ -4148,7 +4148,9 @@
         <p:nvSpPr>
           <p:cNvPr id="1" name="TextBox 3"/>
           <p:cNvSpPr txBox="1"/>
-          <p:nvPr/>
+          <p:nvPr>
+            <p:ph idx="1"/>
+          </p:nvPr>
         </p:nvSpPr>
         <p:spPr>
           <a:xfrm>

</xml_diff>

<commit_message>
Deploying to gh-pages from @ w4bo/slides-markdown@8bb537e86971c69c431c13d3545aefecb81468ed 🚀
</commit_message>
<xml_diff>
--- a/prova.pptx
+++ b/prova.pptx
@@ -16,6 +16,7 @@
     <p:sldId id="264" r:id="rId10"/>
     <p:sldId id="265" r:id="rId11"/>
     <p:sldId id="266" r:id="rId12"/>
+    <p:sldId id="267" r:id="rId13"/>
   </p:sldIdLst>
   <p:sldSz cx="9144000" cy="5143500" type="screen16x9"/>
   <p:notesSz cx="6858000" cy="9144000"/>
@@ -3601,6 +3602,752 @@
             </a:pPr>
             <a:r>
               <a:rPr/>
+              <a:t>Python generated SVG</a:t>
+            </a:r>
+          </a:p>
+        </p:txBody>
+      </p:sp>
+      <p:sp>
+        <p:nvSpPr>
+          <p:cNvPr id="3" name="Content Placeholder 2"/>
+          <p:cNvSpPr>
+            <a:spLocks noGrp="1"/>
+          </p:cNvSpPr>
+          <p:nvPr>
+            <p:ph idx="1" sz="half"/>
+          </p:nvPr>
+        </p:nvSpPr>
+        <p:spPr/>
+        <p:txBody>
+          <a:bodyPr/>
+          <a:lstStyle/>
+          <a:p>
+            <a:pPr lvl="0" indent="0" marL="0">
+              <a:spcBef>
+                <a:spcPts val="3000"/>
+              </a:spcBef>
+              <a:buNone/>
+            </a:pPr>
+            <a:r>
+              <a:rPr b="1"/>
+              <a:t>Executed Python</a:t>
+            </a:r>
+          </a:p>
+          <a:p>
+            <a:pPr lvl="0" indent="0">
+              <a:buNone/>
+            </a:pPr>
+            <a:r>
+              <a:rPr b="1">
+                <a:solidFill>
+                  <a:srgbClr val="008000"/>
+                </a:solidFill>
+                <a:latin typeface="Courier"/>
+              </a:rPr>
+              <a:t>from</a:t>
+            </a:r>
+            <a:r>
+              <a:rPr>
+                <a:latin typeface="Courier"/>
+              </a:rPr>
+              <a:t> pathlib </a:t>
+            </a:r>
+            <a:r>
+              <a:rPr b="1">
+                <a:solidFill>
+                  <a:srgbClr val="008000"/>
+                </a:solidFill>
+                <a:latin typeface="Courier"/>
+              </a:rPr>
+              <a:t>import</a:t>
+            </a:r>
+            <a:r>
+              <a:rPr>
+                <a:latin typeface="Courier"/>
+              </a:rPr>
+              <a:t> Path</a:t>
+            </a:r>
+            <a:br/>
+            <a:r>
+              <a:rPr b="1">
+                <a:solidFill>
+                  <a:srgbClr val="008000"/>
+                </a:solidFill>
+                <a:latin typeface="Courier"/>
+              </a:rPr>
+              <a:t>import</a:t>
+            </a:r>
+            <a:r>
+              <a:rPr>
+                <a:latin typeface="Courier"/>
+              </a:rPr>
+              <a:t> matplotlib.pyplot </a:t>
+            </a:r>
+            <a:r>
+              <a:rPr b="1">
+                <a:solidFill>
+                  <a:srgbClr val="008000"/>
+                </a:solidFill>
+                <a:latin typeface="Courier"/>
+              </a:rPr>
+              <a:t>as</a:t>
+            </a:r>
+            <a:r>
+              <a:rPr>
+                <a:latin typeface="Courier"/>
+              </a:rPr>
+              <a:t> plt</a:t>
+            </a:r>
+            <a:br/>
+            <a:br/>
+            <a:r>
+              <a:rPr>
+                <a:latin typeface="Courier"/>
+              </a:rPr>
+              <a:t>output </a:t>
+            </a:r>
+            <a:r>
+              <a:rPr>
+                <a:solidFill>
+                  <a:srgbClr val="666666"/>
+                </a:solidFill>
+                <a:latin typeface="Courier"/>
+              </a:rPr>
+              <a:t>=</a:t>
+            </a:r>
+            <a:r>
+              <a:rPr>
+                <a:latin typeface="Courier"/>
+              </a:rPr>
+              <a:t> Path(</a:t>
+            </a:r>
+            <a:r>
+              <a:rPr>
+                <a:solidFill>
+                  <a:srgbClr val="4070A0"/>
+                </a:solidFill>
+                <a:latin typeface="Courier"/>
+              </a:rPr>
+              <a:t>"generated-python.svg"</a:t>
+            </a:r>
+            <a:r>
+              <a:rPr>
+                <a:latin typeface="Courier"/>
+              </a:rPr>
+              <a:t>)</a:t>
+            </a:r>
+            <a:br/>
+            <a:br/>
+            <a:r>
+              <a:rPr>
+                <a:latin typeface="Courier"/>
+              </a:rPr>
+              <a:t>fig, ax </a:t>
+            </a:r>
+            <a:r>
+              <a:rPr>
+                <a:solidFill>
+                  <a:srgbClr val="666666"/>
+                </a:solidFill>
+                <a:latin typeface="Courier"/>
+              </a:rPr>
+              <a:t>=</a:t>
+            </a:r>
+            <a:r>
+              <a:rPr>
+                <a:latin typeface="Courier"/>
+              </a:rPr>
+              <a:t> plt.subplots(figsize</a:t>
+            </a:r>
+            <a:r>
+              <a:rPr>
+                <a:solidFill>
+                  <a:srgbClr val="666666"/>
+                </a:solidFill>
+                <a:latin typeface="Courier"/>
+              </a:rPr>
+              <a:t>=</a:t>
+            </a:r>
+            <a:r>
+              <a:rPr>
+                <a:latin typeface="Courier"/>
+              </a:rPr>
+              <a:t>(</a:t>
+            </a:r>
+            <a:r>
+              <a:rPr>
+                <a:solidFill>
+                  <a:srgbClr val="40A070"/>
+                </a:solidFill>
+                <a:latin typeface="Courier"/>
+              </a:rPr>
+              <a:t>5.2</a:t>
+            </a:r>
+            <a:r>
+              <a:rPr>
+                <a:latin typeface="Courier"/>
+              </a:rPr>
+              <a:t>, </a:t>
+            </a:r>
+            <a:r>
+              <a:rPr>
+                <a:solidFill>
+                  <a:srgbClr val="40A070"/>
+                </a:solidFill>
+                <a:latin typeface="Courier"/>
+              </a:rPr>
+              <a:t>3.2</a:t>
+            </a:r>
+            <a:r>
+              <a:rPr>
+                <a:latin typeface="Courier"/>
+              </a:rPr>
+              <a:t>))</a:t>
+            </a:r>
+            <a:br/>
+            <a:r>
+              <a:rPr>
+                <a:latin typeface="Courier"/>
+              </a:rPr>
+              <a:t>categories </a:t>
+            </a:r>
+            <a:r>
+              <a:rPr>
+                <a:solidFill>
+                  <a:srgbClr val="666666"/>
+                </a:solidFill>
+                <a:latin typeface="Courier"/>
+              </a:rPr>
+              <a:t>=</a:t>
+            </a:r>
+            <a:r>
+              <a:rPr>
+                <a:latin typeface="Courier"/>
+              </a:rPr>
+              <a:t> [</a:t>
+            </a:r>
+            <a:r>
+              <a:rPr>
+                <a:solidFill>
+                  <a:srgbClr val="4070A0"/>
+                </a:solidFill>
+                <a:latin typeface="Courier"/>
+              </a:rPr>
+              <a:t>"Alpha"</a:t>
+            </a:r>
+            <a:r>
+              <a:rPr>
+                <a:latin typeface="Courier"/>
+              </a:rPr>
+              <a:t>, </a:t>
+            </a:r>
+            <a:r>
+              <a:rPr>
+                <a:solidFill>
+                  <a:srgbClr val="4070A0"/>
+                </a:solidFill>
+                <a:latin typeface="Courier"/>
+              </a:rPr>
+              <a:t>"Beta"</a:t>
+            </a:r>
+            <a:r>
+              <a:rPr>
+                <a:latin typeface="Courier"/>
+              </a:rPr>
+              <a:t>, </a:t>
+            </a:r>
+            <a:r>
+              <a:rPr>
+                <a:solidFill>
+                  <a:srgbClr val="4070A0"/>
+                </a:solidFill>
+                <a:latin typeface="Courier"/>
+              </a:rPr>
+              <a:t>"Gamma"</a:t>
+            </a:r>
+            <a:r>
+              <a:rPr>
+                <a:latin typeface="Courier"/>
+              </a:rPr>
+              <a:t>, </a:t>
+            </a:r>
+            <a:r>
+              <a:rPr>
+                <a:solidFill>
+                  <a:srgbClr val="4070A0"/>
+                </a:solidFill>
+                <a:latin typeface="Courier"/>
+              </a:rPr>
+              <a:t>"Delta"</a:t>
+            </a:r>
+            <a:r>
+              <a:rPr>
+                <a:latin typeface="Courier"/>
+              </a:rPr>
+              <a:t>]</a:t>
+            </a:r>
+            <a:br/>
+            <a:r>
+              <a:rPr>
+                <a:latin typeface="Courier"/>
+              </a:rPr>
+              <a:t>values </a:t>
+            </a:r>
+            <a:r>
+              <a:rPr>
+                <a:solidFill>
+                  <a:srgbClr val="666666"/>
+                </a:solidFill>
+                <a:latin typeface="Courier"/>
+              </a:rPr>
+              <a:t>=</a:t>
+            </a:r>
+            <a:r>
+              <a:rPr>
+                <a:latin typeface="Courier"/>
+              </a:rPr>
+              <a:t> [</a:t>
+            </a:r>
+            <a:r>
+              <a:rPr>
+                <a:solidFill>
+                  <a:srgbClr val="40A070"/>
+                </a:solidFill>
+                <a:latin typeface="Courier"/>
+              </a:rPr>
+              <a:t>3</a:t>
+            </a:r>
+            <a:r>
+              <a:rPr>
+                <a:latin typeface="Courier"/>
+              </a:rPr>
+              <a:t>, </a:t>
+            </a:r>
+            <a:r>
+              <a:rPr>
+                <a:solidFill>
+                  <a:srgbClr val="40A070"/>
+                </a:solidFill>
+                <a:latin typeface="Courier"/>
+              </a:rPr>
+              <a:t>7</a:t>
+            </a:r>
+            <a:r>
+              <a:rPr>
+                <a:latin typeface="Courier"/>
+              </a:rPr>
+              <a:t>, </a:t>
+            </a:r>
+            <a:r>
+              <a:rPr>
+                <a:solidFill>
+                  <a:srgbClr val="40A070"/>
+                </a:solidFill>
+                <a:latin typeface="Courier"/>
+              </a:rPr>
+              <a:t>5</a:t>
+            </a:r>
+            <a:r>
+              <a:rPr>
+                <a:latin typeface="Courier"/>
+              </a:rPr>
+              <a:t>, </a:t>
+            </a:r>
+            <a:r>
+              <a:rPr>
+                <a:solidFill>
+                  <a:srgbClr val="40A070"/>
+                </a:solidFill>
+                <a:latin typeface="Courier"/>
+              </a:rPr>
+              <a:t>9</a:t>
+            </a:r>
+            <a:r>
+              <a:rPr>
+                <a:latin typeface="Courier"/>
+              </a:rPr>
+              <a:t>]</a:t>
+            </a:r>
+            <a:br/>
+            <a:br/>
+            <a:r>
+              <a:rPr>
+                <a:latin typeface="Courier"/>
+              </a:rPr>
+              <a:t>ax.bar(categories, values, color</a:t>
+            </a:r>
+            <a:r>
+              <a:rPr>
+                <a:solidFill>
+                  <a:srgbClr val="666666"/>
+                </a:solidFill>
+                <a:latin typeface="Courier"/>
+              </a:rPr>
+              <a:t>=</a:t>
+            </a:r>
+            <a:r>
+              <a:rPr>
+                <a:latin typeface="Courier"/>
+              </a:rPr>
+              <a:t>[</a:t>
+            </a:r>
+            <a:r>
+              <a:rPr>
+                <a:solidFill>
+                  <a:srgbClr val="4070A0"/>
+                </a:solidFill>
+                <a:latin typeface="Courier"/>
+              </a:rPr>
+              <a:t>"#669BBC"</a:t>
+            </a:r>
+            <a:r>
+              <a:rPr>
+                <a:latin typeface="Courier"/>
+              </a:rPr>
+              <a:t>, </a:t>
+            </a:r>
+            <a:r>
+              <a:rPr>
+                <a:solidFill>
+                  <a:srgbClr val="4070A0"/>
+                </a:solidFill>
+                <a:latin typeface="Courier"/>
+              </a:rPr>
+              <a:t>"#E4572E"</a:t>
+            </a:r>
+            <a:r>
+              <a:rPr>
+                <a:latin typeface="Courier"/>
+              </a:rPr>
+              <a:t>, </a:t>
+            </a:r>
+            <a:r>
+              <a:rPr>
+                <a:solidFill>
+                  <a:srgbClr val="4070A0"/>
+                </a:solidFill>
+                <a:latin typeface="Courier"/>
+              </a:rPr>
+              <a:t>"#29335C"</a:t>
+            </a:r>
+            <a:r>
+              <a:rPr>
+                <a:latin typeface="Courier"/>
+              </a:rPr>
+              <a:t>, </a:t>
+            </a:r>
+            <a:r>
+              <a:rPr>
+                <a:solidFill>
+                  <a:srgbClr val="4070A0"/>
+                </a:solidFill>
+                <a:latin typeface="Courier"/>
+              </a:rPr>
+              <a:t>"#A8DADC"</a:t>
+            </a:r>
+            <a:r>
+              <a:rPr>
+                <a:latin typeface="Courier"/>
+              </a:rPr>
+              <a:t>])</a:t>
+            </a:r>
+            <a:br/>
+            <a:r>
+              <a:rPr>
+                <a:latin typeface="Courier"/>
+              </a:rPr>
+              <a:t>ax.set_title(</a:t>
+            </a:r>
+            <a:r>
+              <a:rPr>
+                <a:solidFill>
+                  <a:srgbClr val="4070A0"/>
+                </a:solidFill>
+                <a:latin typeface="Courier"/>
+              </a:rPr>
+              <a:t>"SVG generated with matplotlib"</a:t>
+            </a:r>
+            <a:r>
+              <a:rPr>
+                <a:latin typeface="Courier"/>
+              </a:rPr>
+              <a:t>)</a:t>
+            </a:r>
+            <a:br/>
+            <a:r>
+              <a:rPr>
+                <a:latin typeface="Courier"/>
+              </a:rPr>
+              <a:t>ax.set_ylabel(</a:t>
+            </a:r>
+            <a:r>
+              <a:rPr>
+                <a:solidFill>
+                  <a:srgbClr val="4070A0"/>
+                </a:solidFill>
+                <a:latin typeface="Courier"/>
+              </a:rPr>
+              <a:t>"Value"</a:t>
+            </a:r>
+            <a:r>
+              <a:rPr>
+                <a:latin typeface="Courier"/>
+              </a:rPr>
+              <a:t>)</a:t>
+            </a:r>
+            <a:br/>
+            <a:r>
+              <a:rPr>
+                <a:latin typeface="Courier"/>
+              </a:rPr>
+              <a:t>ax.spines[[</a:t>
+            </a:r>
+            <a:r>
+              <a:rPr>
+                <a:solidFill>
+                  <a:srgbClr val="4070A0"/>
+                </a:solidFill>
+                <a:latin typeface="Courier"/>
+              </a:rPr>
+              <a:t>"top"</a:t>
+            </a:r>
+            <a:r>
+              <a:rPr>
+                <a:latin typeface="Courier"/>
+              </a:rPr>
+              <a:t>, </a:t>
+            </a:r>
+            <a:r>
+              <a:rPr>
+                <a:solidFill>
+                  <a:srgbClr val="4070A0"/>
+                </a:solidFill>
+                <a:latin typeface="Courier"/>
+              </a:rPr>
+              <a:t>"right"</a:t>
+            </a:r>
+            <a:r>
+              <a:rPr>
+                <a:latin typeface="Courier"/>
+              </a:rPr>
+              <a:t>]].set_visible(</a:t>
+            </a:r>
+            <a:r>
+              <a:rPr>
+                <a:solidFill>
+                  <a:srgbClr val="19177C"/>
+                </a:solidFill>
+                <a:latin typeface="Courier"/>
+              </a:rPr>
+              <a:t>False</a:t>
+            </a:r>
+            <a:r>
+              <a:rPr>
+                <a:latin typeface="Courier"/>
+              </a:rPr>
+              <a:t>)</a:t>
+            </a:r>
+            <a:br/>
+            <a:r>
+              <a:rPr>
+                <a:latin typeface="Courier"/>
+              </a:rPr>
+              <a:t>ax.grid(axis</a:t>
+            </a:r>
+            <a:r>
+              <a:rPr>
+                <a:solidFill>
+                  <a:srgbClr val="666666"/>
+                </a:solidFill>
+                <a:latin typeface="Courier"/>
+              </a:rPr>
+              <a:t>=</a:t>
+            </a:r>
+            <a:r>
+              <a:rPr>
+                <a:solidFill>
+                  <a:srgbClr val="4070A0"/>
+                </a:solidFill>
+                <a:latin typeface="Courier"/>
+              </a:rPr>
+              <a:t>"y"</a:t>
+            </a:r>
+            <a:r>
+              <a:rPr>
+                <a:latin typeface="Courier"/>
+              </a:rPr>
+              <a:t>, alpha</a:t>
+            </a:r>
+            <a:r>
+              <a:rPr>
+                <a:solidFill>
+                  <a:srgbClr val="666666"/>
+                </a:solidFill>
+                <a:latin typeface="Courier"/>
+              </a:rPr>
+              <a:t>=</a:t>
+            </a:r>
+            <a:r>
+              <a:rPr>
+                <a:solidFill>
+                  <a:srgbClr val="40A070"/>
+                </a:solidFill>
+                <a:latin typeface="Courier"/>
+              </a:rPr>
+              <a:t>0.25</a:t>
+            </a:r>
+            <a:r>
+              <a:rPr>
+                <a:latin typeface="Courier"/>
+              </a:rPr>
+              <a:t>)</a:t>
+            </a:r>
+            <a:br/>
+            <a:br/>
+            <a:r>
+              <a:rPr>
+                <a:latin typeface="Courier"/>
+              </a:rPr>
+              <a:t>fig.tight_layout()</a:t>
+            </a:r>
+            <a:br/>
+            <a:r>
+              <a:rPr>
+                <a:latin typeface="Courier"/>
+              </a:rPr>
+              <a:t>fig.savefig(output, </a:t>
+            </a:r>
+            <a:r>
+              <a:rPr>
+                <a:solidFill>
+                  <a:srgbClr val="008000"/>
+                </a:solidFill>
+                <a:latin typeface="Courier"/>
+              </a:rPr>
+              <a:t>format</a:t>
+            </a:r>
+            <a:r>
+              <a:rPr>
+                <a:solidFill>
+                  <a:srgbClr val="666666"/>
+                </a:solidFill>
+                <a:latin typeface="Courier"/>
+              </a:rPr>
+              <a:t>=</a:t>
+            </a:r>
+            <a:r>
+              <a:rPr>
+                <a:solidFill>
+                  <a:srgbClr val="4070A0"/>
+                </a:solidFill>
+                <a:latin typeface="Courier"/>
+              </a:rPr>
+              <a:t>"svg"</a:t>
+            </a:r>
+            <a:r>
+              <a:rPr>
+                <a:latin typeface="Courier"/>
+              </a:rPr>
+              <a:t>)</a:t>
+            </a:r>
+            <a:br/>
+            <a:r>
+              <a:rPr>
+                <a:latin typeface="Courier"/>
+              </a:rPr>
+              <a:t>plt.close(fig)</a:t>
+            </a:r>
+          </a:p>
+        </p:txBody>
+      </p:sp>
+      <p:sp>
+        <p:nvSpPr>
+          <p:cNvPr id="4" name="Content Placeholder 3"/>
+          <p:cNvSpPr>
+            <a:spLocks noGrp="1"/>
+          </p:cNvSpPr>
+          <p:nvPr>
+            <p:ph idx="2" sz="half"/>
+          </p:nvPr>
+        </p:nvSpPr>
+        <p:spPr/>
+        <p:txBody>
+          <a:bodyPr/>
+          <a:lstStyle/>
+          <a:p>
+            <a:pPr lvl="0" indent="0" marL="0">
+              <a:spcBef>
+                <a:spcPts val="3000"/>
+              </a:spcBef>
+              <a:buNone/>
+            </a:pPr>
+            <a:r>
+              <a:rPr b="1"/>
+              <a:t>Generated SVG</a:t>
+            </a:r>
+          </a:p>
+          <a:p>
+            <a:pPr lvl="0" indent="0" marL="0">
+              <a:buNone/>
+            </a:pPr>
+            <a:r>
+              <a:rPr/>
+              <a:t>SVG generated by the Python chunk</a:t>
+            </a:r>
+          </a:p>
+          <a:p>
+            <a:pPr lvl="0" indent="0" marL="0">
+              <a:buNone/>
+            </a:pPr>
+            <a:r>
+              <a:rPr/>
+              <a:t>SVG generated by the Python chunk</a:t>
+            </a:r>
+          </a:p>
+        </p:txBody>
+      </p:sp>
+    </p:spTree>
+  </p:cSld>
+</p:sld>
+</file>
+
+<file path=ppt/slides/slide12.xml><?xml version="1.0" encoding="utf-8"?>
+<p:sld xmlns:a="http://schemas.openxmlformats.org/drawingml/2006/main" xmlns:r="http://schemas.openxmlformats.org/officeDocument/2006/relationships" xmlns:p="http://schemas.openxmlformats.org/presentationml/2006/main">
+  <p:cSld>
+    <p:spTree>
+      <p:nvGrpSpPr>
+        <p:cNvPr id="1" name=""/>
+        <p:cNvGrpSpPr/>
+        <p:nvPr/>
+      </p:nvGrpSpPr>
+      <p:grpSpPr>
+        <a:xfrm>
+          <a:off x="0" y="0"/>
+          <a:ext cx="0" cy="0"/>
+          <a:chOff x="0" y="0"/>
+          <a:chExt cx="0" cy="0"/>
+        </a:xfrm>
+      </p:grpSpPr>
+      <p:sp>
+        <p:nvSpPr>
+          <p:cNvPr id="2" name="Title 1"/>
+          <p:cNvSpPr>
+            <a:spLocks noGrp="1"/>
+          </p:cNvSpPr>
+          <p:nvPr>
+            <p:ph type="title"/>
+          </p:nvPr>
+        </p:nvSpPr>
+        <p:spPr/>
+        <p:txBody>
+          <a:bodyPr/>
+          <a:lstStyle/>
+          <a:p>
+            <a:pPr lvl="0" indent="0" marL="0">
+              <a:buNone/>
+            </a:pPr>
+            <a:r>
+              <a:rPr/>
               <a:t>References</a:t>
             </a:r>
           </a:p>
@@ -3716,7 +4463,7 @@
             </a:pPr>
             <a:r>
               <a:rPr/>
-              <a:t>Left column (Francia et al. 2024)</a:t>
+              <a:t>Left column (Francia, Gallinucci, and Golfarelli 2024)</a:t>
             </a:r>
           </a:p>
           <a:p>
@@ -4148,9 +4895,7 @@
         <p:nvSpPr>
           <p:cNvPr id="1" name="TextBox 3"/>
           <p:cNvSpPr txBox="1"/>
-          <p:nvPr>
-            <p:ph idx="1"/>
-          </p:nvPr>
+          <p:nvPr/>
         </p:nvSpPr>
         <p:spPr>
           <a:xfrm>

</xml_diff>